<commit_message>
Video học liệu chỉ từ nguồn chính thống; gỡ đề có đáp án (mon/*/trac_nghiem) khỏi kho công khai
Co-Authored-By: Claude Opus 5.5 <noreply@anthropic.com>
</commit_message>
<xml_diff>
--- a/mon/ngu_van/slide/lop11/Slide_NGUVAN11_Bai1_CauChuyenVaDiemNhin_T1-11.pptx
+++ b/mon/ngu_van/slide/lop11/Slide_NGUVAN11_Bai1_CauChuyenVaDiemNhin_T1-11.pptx
@@ -1175,7 +1175,7 @@
           <a:lstStyle/>
           <a:p>
             <a:r>
-              <a:t>Bấm vào đường link hoặc quét mã QR để mở video (cần Internet). Phim truyện dài; GV chọn trích đoạn bát cháo hành, không chiếu toàn bộ.</a:t>
+              <a:t>Bấm vào đường link hoặc quét mã QR để mở video (cần Internet). </a:t>
             </a:r>
           </a:p>
         </p:txBody>
@@ -2085,7 +2085,7 @@
           <a:lstStyle/>
           <a:p>
             <a:r>
-              <a:t>Bấm vào đường link hoặc quét mã QR để mở video (cần Internet). Phim tư liệu có hình ảnh nặng nề – chỉ chiếu trích đoạn ngắn.</a:t>
+              <a:t>Bấm vào đường link hoặc quét mã QR để mở video (cần Internet). Phim tư liệu có hình ảnh nặng nề – GV xem trước.</a:t>
             </a:r>
           </a:p>
         </p:txBody>
@@ -10864,7 +10864,7 @@
       </p:sp>
       <p:pic>
         <p:nvPicPr>
-          <p:cNvPr id="7" name="Picture 6" descr="QR_video_FShtDV29lXQ.png"/>
+          <p:cNvPr id="7" name="Picture 6" descr="QR_video_EDUX_REhg-0.png"/>
           <p:cNvPicPr>
             <a:picLocks noChangeAspect="1"/>
           </p:cNvPicPr>
@@ -10920,7 +10920,7 @@
                 </a:solidFill>
                 <a:latin typeface="Calibri"/>
               </a:rPr>
-              <a:t>🎬 Làng Vũ Đại ngày ấy (1982)</a:t>
+              <a:t>🎬 Trước giờ xem phim “Làng Vũ Đại ngày ấy”</a:t>
             </a:r>
           </a:p>
           <a:p>
@@ -10936,7 +10936,7 @@
                 </a:solidFill>
                 <a:latin typeface="Calibri"/>
               </a:rPr>
-              <a:t>Kênh: Sao Vàng</a:t>
+              <a:t>Kênh: VTV24</a:t>
             </a:r>
           </a:p>
           <a:p>
@@ -10957,7 +10957,7 @@
                 </a:solidFill>
                 <a:latin typeface="Calibri"/>
               </a:rPr>
-              <a:t>Mở đầu Chí Phèo – chiếu trích đoạn phim chuyển thể (Chí Phèo – Thị Nở)</a:t>
+              <a:t>Mở đầu Chí Phèo – giới thiệu phim chuyển thể từ tác phẩm Nam Cao</a:t>
             </a:r>
           </a:p>
           <a:p>
@@ -10974,7 +10974,7 @@
                 <a:latin typeface="Calibri"/>
                 <a:hlinkClick r:id="rId3"/>
               </a:rPr>
-              <a:t>https://www.youtube.com/watch?v=FShtDV29lXQ</a:t>
+              <a:t>https://www.youtube.com/watch?v=EDUX_REhg-0</a:t>
             </a:r>
           </a:p>
         </p:txBody>
@@ -19422,7 +19422,7 @@
       </p:sp>
       <p:pic>
         <p:nvPicPr>
-          <p:cNvPr id="7" name="Picture 6" descr="QR_video_l00C8vSGTso.png"/>
+          <p:cNvPr id="7" name="Picture 6" descr="QR_video_QTEXDAI5g2A.png"/>
           <p:cNvPicPr>
             <a:picLocks noChangeAspect="1"/>
           </p:cNvPicPr>
@@ -19478,7 +19478,7 @@
                 </a:solidFill>
                 <a:latin typeface="Calibri"/>
               </a:rPr>
-              <a:t>🎬 Phim tài liệu đặc biệt: Nạn đói khủng khiếp năm 1945</a:t>
+              <a:t>🎬 Nạn đói 1945: Thảm cảnh đầy nước mắt</a:t>
             </a:r>
           </a:p>
           <a:p>
@@ -19494,7 +19494,7 @@
                 </a:solidFill>
                 <a:latin typeface="Calibri"/>
               </a:rPr>
-              <a:t>Kênh: Trực tiếp TV</a:t>
+              <a:t>Kênh: Kênh VTC16 (Đài THVN)</a:t>
             </a:r>
           </a:p>
           <a:p>
@@ -19515,7 +19515,7 @@
                 </a:solidFill>
                 <a:latin typeface="Calibri"/>
               </a:rPr>
-              <a:t>Hoạt động Mở đầu – Vợ nhặt (chiếu trích đoạn 2–3 phút)</a:t>
+              <a:t>Hoạt động Mở đầu – Vợ nhặt (3 phút)</a:t>
             </a:r>
           </a:p>
           <a:p>
@@ -19532,7 +19532,7 @@
                 <a:latin typeface="Calibri"/>
                 <a:hlinkClick r:id="rId3"/>
               </a:rPr>
-              <a:t>https://www.youtube.com/watch?v=l00C8vSGTso</a:t>
+              <a:t>https://www.youtube.com/watch?v=QTEXDAI5g2A</a:t>
             </a:r>
           </a:p>
         </p:txBody>
@@ -20145,7 +20145,7 @@
       </p:sp>
       <p:pic>
         <p:nvPicPr>
-          <p:cNvPr id="7" name="Picture 6" descr="QR_video_6PGr8iYB83I.png"/>
+          <p:cNvPr id="7" name="Picture 6" descr="QR_video_g79uSESWGdA.png"/>
           <p:cNvPicPr>
             <a:picLocks noChangeAspect="1"/>
           </p:cNvPicPr>
@@ -20201,7 +20201,7 @@
                 </a:solidFill>
                 <a:latin typeface="Calibri"/>
               </a:rPr>
-              <a:t>🎬 Tác phẩm: Truyện ngắn Vợ nhặt – Nhà văn Kim Lân</a:t>
+              <a:t>🎬 Truyện ngắn Vợ nhặt – Kim Lân (Chương trình Thư viện sách nói)</a:t>
             </a:r>
           </a:p>
           <a:p>
@@ -20217,7 +20217,7 @@
                 </a:solidFill>
                 <a:latin typeface="Calibri"/>
               </a:rPr>
-              <a:t>Kênh: Văn học Việt Nam và Thế giới</a:t>
+              <a:t>Kênh: Thư viện Thành phố Bắc Giang</a:t>
             </a:r>
           </a:p>
           <a:p>
@@ -20238,7 +20238,7 @@
                 </a:solidFill>
                 <a:latin typeface="Calibri"/>
               </a:rPr>
-              <a:t>Đọc văn bản ở nhà (nghe toàn văn truyện)</a:t>
+              <a:t>Giao HS nghe toàn văn ở nhà</a:t>
             </a:r>
           </a:p>
           <a:p>
@@ -20255,7 +20255,7 @@
                 <a:latin typeface="Calibri"/>
                 <a:hlinkClick r:id="rId3"/>
               </a:rPr>
-              <a:t>https://www.youtube.com/watch?v=6PGr8iYB83I</a:t>
+              <a:t>https://www.youtube.com/watch?v=g79uSESWGdA</a:t>
             </a:r>
           </a:p>
         </p:txBody>

</xml_diff>